<commit_message>
update docs and slides with improved metrics and ui screenshot
</commit_message>
<xml_diff>
--- a/slides.pptx
+++ b/slides.pptx
@@ -4572,7 +4572,7 @@
                 </a:solidFill>
                 <a:latin typeface="Calibri"/>
               </a:rPr>
-              <a:t>•  AutoML.fit przeszukuje estymatory (lgbm, rf, extra_tree) w zadanym budżecie czasu.</a:t>
+              <a:t>•  AutoML.fit przeszukuje estymatory (lgbm, rf, extra_tree) i składa je w ensemble (stacking).</a:t>
             </a:r>
           </a:p>
           <a:p>
@@ -4808,7 +4808,7 @@
                 </a:solidFill>
                 <a:latin typeface="Trebuchet MS"/>
               </a:rPr>
-              <a:t>6,4</a:t>
+              <a:t>6,1</a:t>
             </a:r>
           </a:p>
           <a:p>
@@ -4875,7 +4875,7 @@
                 </a:solidFill>
                 <a:latin typeface="Trebuchet MS"/>
               </a:rPr>
-              <a:t>9,3</a:t>
+              <a:t>9,0</a:t>
             </a:r>
           </a:p>
           <a:p>
@@ -4942,7 +4942,7 @@
                 </a:solidFill>
                 <a:latin typeface="Trebuchet MS"/>
               </a:rPr>
-              <a:t>0,81</a:t>
+              <a:t>0,82</a:t>
             </a:r>
           </a:p>
           <a:p>
@@ -4993,7 +4993,7 @@
                 </a:solidFill>
                 <a:latin typeface="Calibri"/>
               </a:rPr>
-              <a:t>Najlepszy estymator: LightGBM · ocena na 20% zbiorze testowym · najważniejsza cecha: dystans.</a:t>
+              <a:t>Model: FLAML ensemble (baza LightGBM) · ocena na 20% holdout · najważniejsza cecha: dystans.</a:t>
             </a:r>
           </a:p>
         </p:txBody>

</xml_diff>

<commit_message>
pivot docs + slides to laptop topic
</commit_message>
<xml_diff>
--- a/slides.pptx
+++ b/slides.pptx
@@ -3177,13 +3177,13 @@
               </a:spcAft>
             </a:pPr>
             <a:r>
-              <a:rPr sz="5400" b="1">
+              <a:rPr sz="5200" b="1">
                 <a:solidFill>
                   <a:srgbClr val="FFFFFF"/>
                 </a:solidFill>
                 <a:latin typeface="Trebuchet MS"/>
               </a:rPr>
-              <a:t>Food Delivery ETA</a:t>
+              <a:t>Laptop Price Predictor</a:t>
             </a:r>
           </a:p>
         </p:txBody>
@@ -3222,7 +3222,7 @@
                 </a:solidFill>
                 <a:latin typeface="Calibri"/>
               </a:rPr>
-              <a:t>Predykcja czasu dostawy jedzenia — AutoML, FastAPI, Streamlit, Docker</a:t>
+              <a:t>Predykcja ceny laptopa ze specyfikacji — AutoML, FastAPI, Streamlit, Docker</a:t>
             </a:r>
           </a:p>
         </p:txBody>
@@ -3448,7 +3448,7 @@
                 </a:solidFill>
                 <a:latin typeface="Calibri"/>
               </a:rPr>
-              <a:t>•  Demo: docker compose up --build → UI :8501, API :8000/docs → predykcja na żywo.</a:t>
+              <a:t>•  Demo: docker compose up --build → UI :8501, API :8000/docs → wycena na żywo.</a:t>
             </a:r>
           </a:p>
           <a:p>
@@ -3667,7 +3667,7 @@
                 </a:solidFill>
                 <a:latin typeface="Calibri"/>
               </a:rPr>
-              <a:t>•  Platformy dostaw (Wolt, Glovo, Uber Eats) potrzebują trafnego ETA już w momencie zamówienia.</a:t>
+              <a:t>•  Wycena laptopa wprost wpływa na sprzedaż i marżę (sklepy, marketplace, wycena używanego sprzętu).</a:t>
             </a:r>
           </a:p>
           <a:p>
@@ -3683,7 +3683,7 @@
                 </a:solidFill>
                 <a:latin typeface="Calibri"/>
               </a:rPr>
-              <a:t>•  Dobre ETA = realne oczekiwania klienta, sprawniejsza dyspozycja kurierów i wczesne flagowanie opóźnień.</a:t>
+              <a:t>•  Za drogo — nie sprzeda się; za tanio — tracimy marżę.</a:t>
             </a:r>
           </a:p>
           <a:p>
@@ -3699,14 +3699,14 @@
                 </a:solidFill>
                 <a:latin typeface="Calibri"/>
               </a:rPr>
-              <a:t>•  Aplikacja przewiduje czas dostawy (regresja) na podstawie cech zamówienia, trasy i kontekstu.</a:t>
+              <a:t>•  Aplikacja przewiduje cenę (regresja) z marki, typu, RAM, dysku, ekranu, CPU/GPU i systemu.</a:t>
             </a:r>
           </a:p>
         </p:txBody>
       </p:sp>
       <p:pic>
         <p:nvPicPr>
-          <p:cNvPr id="5" name="Picture 4" descr="distance_vs_time.png"/>
+          <p:cNvPr id="5" name="Picture 4" descr="feature_scatter.png"/>
           <p:cNvPicPr>
             <a:picLocks noChangeAspect="1"/>
           </p:cNvPicPr>
@@ -3720,8 +3720,8 @@
         </p:blipFill>
         <p:spPr>
           <a:xfrm>
-            <a:off x="6949440" y="1920240"/>
-            <a:ext cx="4754880" cy="3566160"/>
+            <a:off x="7040880" y="1920240"/>
+            <a:ext cx="4572000" cy="3429000"/>
           </a:xfrm>
           <a:prstGeom prst="rect">
             <a:avLst/>
@@ -3832,7 +3832,7 @@
                 </a:solidFill>
                 <a:latin typeface="Trebuchet MS"/>
               </a:rPr>
-              <a:t>Dane</a:t>
+              <a:t>Dane i czyszczenie</a:t>
             </a:r>
           </a:p>
         </p:txBody>
@@ -3871,7 +3871,7 @@
                 </a:solidFill>
                 <a:latin typeface="Calibri"/>
               </a:rPr>
-              <a:t>•  Źródło: Kaggle denkuznetz/food-delivery-time-prediction (1000 wierszy, 9 kolumn).</a:t>
+              <a:t>•  Źródło: Kaggle laptop price (1303 wiersze) — dołączony do repo.</a:t>
             </a:r>
           </a:p>
           <a:p>
@@ -3887,7 +3887,7 @@
                 </a:solidFill>
                 <a:latin typeface="Calibri"/>
               </a:rPr>
-              <a:t>•  CSV dołączony do repo + generator danych syntetycznych o tym samym schemacie (fallback).</a:t>
+              <a:t>•  Surowe pola to teksty: RAM "8GB", waga "1.37kg", rozdzielczość/CPU/pamięć.</a:t>
             </a:r>
           </a:p>
           <a:p>
@@ -3903,7 +3903,7 @@
                 </a:solidFill>
                 <a:latin typeface="Calibri"/>
               </a:rPr>
-              <a:t>•  Braki: po 30 w 4 kolumnach → imputacja w pipeline (mediana / najczęstsza wartość).</a:t>
+              <a:t>•  features.py: parsowanie → RAM, waga, PPI, touch/IPS, SSD/HDD, marki CPU/GPU; + czyszczenie złych wierszy.</a:t>
             </a:r>
           </a:p>
           <a:p>
@@ -3919,7 +3919,7 @@
                 </a:solidFill>
                 <a:latin typeface="Calibri"/>
               </a:rPr>
-              <a:t>•  Cel: czas dostawy 8–153 min (średnio ~57).</a:t>
+              <a:t>•  Brak CSV → generator syntetyczny o tym samym schemacie (fallback).</a:t>
             </a:r>
           </a:p>
         </p:txBody>
@@ -3940,8 +3940,8 @@
         </p:blipFill>
         <p:spPr>
           <a:xfrm>
-            <a:off x="7040880" y="2011680"/>
-            <a:ext cx="4572000" cy="3429000"/>
+            <a:off x="7132320" y="2011680"/>
+            <a:ext cx="4480560" cy="3360420"/>
           </a:xfrm>
           <a:prstGeom prst="rect">
             <a:avLst/>
@@ -4111,25 +4111,25 @@
           <a:p>
             <a:pPr algn="ctr"/>
             <a:r>
-              <a:rPr sz="1300">
+              <a:rPr sz="1200">
                 <a:solidFill>
                   <a:srgbClr val="222233"/>
                 </a:solidFill>
                 <a:latin typeface="Calibri"/>
               </a:rPr>
-              <a:t>load + walidacja</a:t>
+              <a:t>load + feature engineering</a:t>
             </a:r>
           </a:p>
           <a:p>
             <a:pPr algn="ctr"/>
             <a:r>
-              <a:rPr sz="1300">
+              <a:rPr sz="1200">
                 <a:solidFill>
                   <a:srgbClr val="222233"/>
                 </a:solidFill>
                 <a:latin typeface="Calibri"/>
               </a:rPr>
-              <a:t>split + preprocessing</a:t>
+              <a:t>czyszczenie + split</a:t>
             </a:r>
           </a:p>
         </p:txBody>
@@ -4188,19 +4188,19 @@
           <a:p>
             <a:pPr algn="ctr"/>
             <a:r>
-              <a:rPr sz="1300">
+              <a:rPr sz="1200">
                 <a:solidFill>
                   <a:srgbClr val="222233"/>
                 </a:solidFill>
                 <a:latin typeface="Calibri"/>
               </a:rPr>
-              <a:t>FLAML AutoML</a:t>
+              <a:t>FLAML AutoML + log-target</a:t>
             </a:r>
           </a:p>
           <a:p>
             <a:pPr algn="ctr"/>
             <a:r>
-              <a:rPr sz="1300">
+              <a:rPr sz="1200">
                 <a:solidFill>
                   <a:srgbClr val="222233"/>
                 </a:solidFill>
@@ -4265,7 +4265,7 @@
           <a:p>
             <a:pPr algn="ctr"/>
             <a:r>
-              <a:rPr sz="1300">
+              <a:rPr sz="1200">
                 <a:solidFill>
                   <a:srgbClr val="222233"/>
                 </a:solidFill>
@@ -4277,7 +4277,7 @@
           <a:p>
             <a:pPr algn="ctr"/>
             <a:r>
-              <a:rPr sz="1300">
+              <a:rPr sz="1200">
                 <a:solidFill>
                   <a:srgbClr val="222233"/>
                 </a:solidFill>
@@ -4572,7 +4572,7 @@
                 </a:solidFill>
                 <a:latin typeface="Calibri"/>
               </a:rPr>
-              <a:t>•  AutoML.fit przeszukuje estymatory (lgbm, rf, extra_tree) i składa je w ensemble (stacking).</a:t>
+              <a:t>•  AutoML.fit przeszukuje estymatory (lgbm, rf, extra_tree) i składa je w ensemble.</a:t>
             </a:r>
           </a:p>
           <a:p>
@@ -4588,7 +4588,7 @@
                 </a:solidFill>
                 <a:latin typeface="Calibri"/>
               </a:rPr>
-              <a:t>•  Cały preprocessing + model zapisany jako jeden sklearn Pipeline (model.joblib).</a:t>
+              <a:t>•  log-target: trenujemy na log(cena), przewidujemy realną cenę (uczciwe R2 w walucie).</a:t>
             </a:r>
           </a:p>
           <a:p>
@@ -4604,7 +4604,7 @@
                 </a:solidFill>
                 <a:latin typeface="Calibri"/>
               </a:rPr>
-              <a:t>•  Imputacja + one-hot w pipeline → spójność trening / serwowanie, bez wycieków.</a:t>
+              <a:t>•  Cały preprocessing + model w jednym sklearn Pipeline (model.joblib).</a:t>
             </a:r>
           </a:p>
           <a:p>
@@ -4620,7 +4620,7 @@
                 </a:solidFill>
                 <a:latin typeface="Calibri"/>
               </a:rPr>
-              <a:t>•  Konfiguracja AutoML w config.yaml (budżet, metryka, lista estymatorów).</a:t>
+              <a:t>•  Ważność cech liczona permutacyjnie (model-agnostic).</a:t>
             </a:r>
           </a:p>
         </p:txBody>
@@ -4802,13 +4802,13 @@
           <a:p>
             <a:pPr algn="ctr"/>
             <a:r>
-              <a:rPr sz="4000" b="1">
+              <a:rPr sz="3800" b="1">
                 <a:solidFill>
                   <a:srgbClr val="028090"/>
                 </a:solidFill>
                 <a:latin typeface="Trebuchet MS"/>
               </a:rPr>
-              <a:t>6,1</a:t>
+              <a:t>0,85</a:t>
             </a:r>
           </a:p>
           <a:p>
@@ -4820,7 +4820,7 @@
                 </a:solidFill>
                 <a:latin typeface="Calibri"/>
               </a:rPr>
-              <a:t>MAE (minuty)</a:t>
+              <a:t>R² (cena, INR)</a:t>
             </a:r>
           </a:p>
         </p:txBody>
@@ -4869,13 +4869,13 @@
           <a:p>
             <a:pPr algn="ctr"/>
             <a:r>
-              <a:rPr sz="4000" b="1">
+              <a:rPr sz="3800" b="1">
                 <a:solidFill>
                   <a:srgbClr val="028090"/>
                 </a:solidFill>
                 <a:latin typeface="Trebuchet MS"/>
               </a:rPr>
-              <a:t>9,0</a:t>
+              <a:t>9,6k</a:t>
             </a:r>
           </a:p>
           <a:p>
@@ -4887,7 +4887,7 @@
                 </a:solidFill>
                 <a:latin typeface="Calibri"/>
               </a:rPr>
-              <a:t>RMSE</a:t>
+              <a:t>MAE (INR)</a:t>
             </a:r>
           </a:p>
         </p:txBody>
@@ -4936,13 +4936,13 @@
           <a:p>
             <a:pPr algn="ctr"/>
             <a:r>
-              <a:rPr sz="4000" b="1">
+              <a:rPr sz="3800" b="1">
                 <a:solidFill>
                   <a:srgbClr val="028090"/>
                 </a:solidFill>
                 <a:latin typeface="Trebuchet MS"/>
               </a:rPr>
-              <a:t>0,82</a:t>
+              <a:t>14,6k</a:t>
             </a:r>
           </a:p>
           <a:p>
@@ -4954,7 +4954,7 @@
                 </a:solidFill>
                 <a:latin typeface="Calibri"/>
               </a:rPr>
-              <a:t>R²</a:t>
+              <a:t>RMSE (INR)</a:t>
             </a:r>
           </a:p>
         </p:txBody>
@@ -4993,7 +4993,7 @@
                 </a:solidFill>
                 <a:latin typeface="Calibri"/>
               </a:rPr>
-              <a:t>Model: FLAML ensemble (baza LightGBM) · ocena na 20% holdout · najważniejsza cecha: dystans.</a:t>
+              <a:t>FLAML ensemble + log-target · 20% holdout · najważniejsze cechy: RAM, SSD, typ, CPU.</a:t>
             </a:r>
           </a:p>
         </p:txBody>
@@ -5177,7 +5177,7 @@
                 </a:solidFill>
                 <a:latin typeface="Calibri"/>
               </a:rPr>
-              <a:t>•  POST /predict — predykcja ETA (minuty)</a:t>
+              <a:t>•  POST /predict — przewidywana cena</a:t>
             </a:r>
           </a:p>
           <a:p>
@@ -5241,7 +5241,7 @@
                 </a:solidFill>
                 <a:latin typeface="Calibri"/>
               </a:rPr>
-              <a:t>•  Walidacja wejścia Pydantic → 422 dla błędnych danych</a:t>
+              <a:t>•  Walidacja wejścia Pydantic → 422</a:t>
             </a:r>
           </a:p>
         </p:txBody>
@@ -5316,7 +5316,7 @@
                 </a:solidFill>
                 <a:latin typeface="Calibri"/>
               </a:rPr>
-              <a:t>•  Formularz cech zamówienia</a:t>
+              <a:t>•  Formularz specyfikacji laptopa</a:t>
             </a:r>
           </a:p>
           <a:p>
@@ -5332,7 +5332,7 @@
                 </a:solidFill>
                 <a:latin typeface="Calibri"/>
               </a:rPr>
-              <a:t>•  Woła API i pokazuje przewidziany czas</a:t>
+              <a:t>•  Woła API i pokazuje cenę</a:t>
             </a:r>
           </a:p>
           <a:p>
@@ -5348,7 +5348,7 @@
                 </a:solidFill>
                 <a:latin typeface="Calibri"/>
               </a:rPr>
-              <a:t>•  Panel z metrykami modelu</a:t>
+              <a:t>•  Tryb standalone (model lokalnie) na Streamlit Cloud</a:t>
             </a:r>
           </a:p>
           <a:p>
@@ -5364,23 +5364,7 @@
                 </a:solidFill>
                 <a:latin typeface="Calibri"/>
               </a:rPr>
-              <a:t>•  Wykres ważności cech</a:t>
-            </a:r>
-          </a:p>
-          <a:p>
-            <a:pPr>
-              <a:spcAft>
-                <a:spcPts val="600"/>
-              </a:spcAft>
-            </a:pPr>
-            <a:r>
-              <a:rPr sz="1500">
-                <a:solidFill>
-                  <a:srgbClr val="222233"/>
-                </a:solidFill>
-                <a:latin typeface="Calibri"/>
-              </a:rPr>
-              <a:t>•  Konfigurowalny adres API (env / config)</a:t>
+              <a:t>•  Panel z metrykami + ważność cech</a:t>
             </a:r>
           </a:p>
         </p:txBody>
@@ -5528,7 +5512,7 @@
                 </a:solidFill>
                 <a:latin typeface="Calibri"/>
               </a:rPr>
-              <a:t>•  docker compose up --build → dwa serwisy: api (FastAPI) + ui (Streamlit).</a:t>
+              <a:t>•  docker compose up --build → dwa serwisy: api + ui.</a:t>
             </a:r>
           </a:p>
           <a:p>
@@ -5544,7 +5528,7 @@
                 </a:solidFill>
                 <a:latin typeface="Calibri"/>
               </a:rPr>
-              <a:t>•  Model trenowany podczas budowania obrazu — gotowy przy pierwszym żądaniu.</a:t>
+              <a:t>•  Model trenowany podczas budowania obrazu — gotowy od razu.</a:t>
             </a:r>
           </a:p>
           <a:p>
@@ -5560,7 +5544,7 @@
                 </a:solidFill>
                 <a:latin typeface="Calibri"/>
               </a:rPr>
-              <a:t>•  Zależności przypięte (requirements.txt); obraz python:3.11-slim, użytkownik non-root.</a:t>
+              <a:t>•  Zależności przypięte; obraz python:3.11-slim, użytkownik non-root.</a:t>
             </a:r>
           </a:p>
           <a:p>
@@ -5576,7 +5560,7 @@
                 </a:solidFill>
                 <a:latin typeface="Calibri"/>
               </a:rPr>
-              <a:t>•  Zero konfiguracji systemu operacyjnego; .gitattributes wymusza końce linii LF.</a:t>
+              <a:t>•  packages.txt (libgomp1 dla LightGBM); .gitattributes wymusza LF.</a:t>
             </a:r>
           </a:p>
           <a:p>
@@ -5804,7 +5788,7 @@
           <a:p>
             <a:pPr algn="ctr"/>
             <a:r>
-              <a:rPr sz="4000" b="1">
+              <a:rPr sz="3800" b="1">
                 <a:solidFill>
                   <a:srgbClr val="028090"/>
                 </a:solidFill>
@@ -5871,13 +5855,13 @@
           <a:p>
             <a:pPr algn="ctr"/>
             <a:r>
-              <a:rPr sz="4000" b="1">
+              <a:rPr sz="3800" b="1">
                 <a:solidFill>
                   <a:srgbClr val="028090"/>
                 </a:solidFill>
                 <a:latin typeface="Trebuchet MS"/>
               </a:rPr>
-              <a:t>26</a:t>
+              <a:t>28</a:t>
             </a:r>
           </a:p>
           <a:p>
@@ -5938,7 +5922,7 @@
           <a:p>
             <a:pPr algn="ctr"/>
             <a:r>
-              <a:rPr sz="4000" b="1">
+              <a:rPr sz="3800" b="1">
                 <a:solidFill>
                   <a:srgbClr val="028090"/>
                 </a:solidFill>
@@ -6011,7 +5995,7 @@
                 </a:solidFill>
                 <a:latin typeface="Calibri"/>
               </a:rPr>
-              <a:t>•  Ścisły podział data | model | app; modularność na poziomie funkcji i katalogów.</a:t>
+              <a:t>•  Ścisły podział data | model | app; modularność funkcji i katalogów.</a:t>
             </a:r>
           </a:p>
           <a:p>
@@ -6027,7 +6011,7 @@
                 </a:solidFill>
                 <a:latin typeface="Calibri"/>
               </a:rPr>
-              <a:t>•  Czytelna historia commitów; spec i plan w docs/.</a:t>
+              <a:t>•  Czysta historia commitów; data card + EDA w docs/.</a:t>
             </a:r>
           </a:p>
         </p:txBody>

</xml_diff>

<commit_message>
business-focused slides + polish ui screenshot
</commit_message>
<xml_diff>
--- a/slides.pptx
+++ b/slides.pptx
@@ -3173,17 +3173,17 @@
           <a:p>
             <a:pPr algn="l">
               <a:spcAft>
-                <a:spcPts val="800"/>
+                <a:spcPts val="1000"/>
               </a:spcAft>
             </a:pPr>
             <a:r>
-              <a:rPr sz="5200" b="1">
+              <a:rPr sz="5400" b="1">
                 <a:solidFill>
                   <a:srgbClr val="FFFFFF"/>
                 </a:solidFill>
                 <a:latin typeface="Trebuchet MS"/>
               </a:rPr>
-              <a:t>Laptop Price Predictor</a:t>
+              <a:t>Wycena laptopa</a:t>
             </a:r>
           </a:p>
         </p:txBody>
@@ -3212,7 +3212,7 @@
           <a:p>
             <a:pPr algn="l">
               <a:spcAft>
-                <a:spcPts val="800"/>
+                <a:spcPts val="1000"/>
               </a:spcAft>
             </a:pPr>
             <a:r>
@@ -3222,7 +3222,7 @@
                 </a:solidFill>
                 <a:latin typeface="Calibri"/>
               </a:rPr>
-              <a:t>Predykcja ceny laptopa ze specyfikacji — AutoML, FastAPI, Streamlit, Docker</a:t>
+              <a:t>Aplikacja, która szacuje cenę laptopa na podstawie jego specyfikacji</a:t>
             </a:r>
           </a:p>
         </p:txBody>
@@ -3251,7 +3251,7 @@
           <a:p>
             <a:pPr algn="l">
               <a:spcAft>
-                <a:spcPts val="800"/>
+                <a:spcPts val="1000"/>
               </a:spcAft>
             </a:pPr>
             <a:r>
@@ -3290,7 +3290,7 @@
           <a:p>
             <a:pPr algn="l">
               <a:spcAft>
-                <a:spcPts val="800"/>
+                <a:spcPts val="1000"/>
               </a:spcAft>
             </a:pPr>
             <a:r>
@@ -3399,7 +3399,7 @@
           <a:p>
             <a:pPr algn="l">
               <a:spcAft>
-                <a:spcPts val="800"/>
+                <a:spcPts val="1000"/>
               </a:spcAft>
             </a:pPr>
             <a:r>
@@ -3409,7 +3409,7 @@
                 </a:solidFill>
                 <a:latin typeface="Trebuchet MS"/>
               </a:rPr>
-              <a:t>Demo i podsumowanie</a:t>
+              <a:t>Podsumowanie i demo</a:t>
             </a:r>
           </a:p>
         </p:txBody>
@@ -3423,7 +3423,7 @@
         <p:spPr>
           <a:xfrm>
             <a:off x="822960" y="1737360"/>
-            <a:ext cx="10424160" cy="3657600"/>
+            <a:ext cx="10424160" cy="3291840"/>
           </a:xfrm>
           <a:prstGeom prst="rect">
             <a:avLst/>
@@ -3438,43 +3438,43 @@
           <a:p>
             <a:pPr algn="l">
               <a:spcAft>
-                <a:spcPts val="1400"/>
+                <a:spcPts val="1600"/>
               </a:spcAft>
             </a:pPr>
             <a:r>
-              <a:rPr sz="1800" b="0">
+              <a:rPr sz="1900" b="0">
                 <a:solidFill>
                   <a:srgbClr val="CADCFC"/>
                 </a:solidFill>
                 <a:latin typeface="Calibri"/>
               </a:rPr>
-              <a:t>•  Demo: docker compose up --build → UI :8501, API :8000/docs → wycena na żywo.</a:t>
+              <a:t>•  Demo na żywo: wpisujemy specyfikację → otrzymujemy cenę.</a:t>
             </a:r>
           </a:p>
           <a:p>
             <a:pPr algn="l">
               <a:spcAft>
-                <a:spcPts val="1400"/>
+                <a:spcPts val="1600"/>
               </a:spcAft>
             </a:pPr>
             <a:r>
-              <a:rPr sz="1800" b="0">
+              <a:rPr sz="1900" b="0">
                 <a:solidFill>
                   <a:srgbClr val="CADCFC"/>
                 </a:solidFill>
                 <a:latin typeface="Calibri"/>
               </a:rPr>
-              <a:t>•  Retraining: nowy CSV w data/raw/ + python -m model.train (bez zmian w kodzie).</a:t>
+              <a:t>•  Łatwe w użyciu, trafne (~85%), gotowe do dotrenowania i integracji.</a:t>
             </a:r>
           </a:p>
           <a:p>
             <a:pPr algn="l">
               <a:spcAft>
-                <a:spcPts val="1400"/>
+                <a:spcPts val="1600"/>
               </a:spcAft>
             </a:pPr>
             <a:r>
-              <a:rPr sz="1800" b="0">
+              <a:rPr sz="1900" b="0">
                 <a:solidFill>
                   <a:srgbClr val="CADCFC"/>
                 </a:solidFill>
@@ -3509,7 +3509,7 @@
           <a:p>
             <a:pPr algn="l">
               <a:spcAft>
-                <a:spcPts val="800"/>
+                <a:spcPts val="1000"/>
               </a:spcAft>
             </a:pPr>
             <a:r>
@@ -3618,7 +3618,7 @@
           <a:p>
             <a:pPr algn="l">
               <a:spcAft>
-                <a:spcPts val="800"/>
+                <a:spcPts val="1000"/>
               </a:spcAft>
             </a:pPr>
             <a:r>
@@ -3628,7 +3628,7 @@
                 </a:solidFill>
                 <a:latin typeface="Trebuchet MS"/>
               </a:rPr>
-              <a:t>Problem i wartość biznesowa</a:t>
+              <a:t>Co to robi i po co</a:t>
             </a:r>
           </a:p>
         </p:txBody>
@@ -3657,49 +3657,49 @@
           <a:p>
             <a:pPr algn="l">
               <a:spcAft>
-                <a:spcPts val="1400"/>
+                <a:spcPts val="1600"/>
               </a:spcAft>
             </a:pPr>
             <a:r>
-              <a:rPr sz="1700" b="0">
+              <a:rPr sz="1800" b="0">
                 <a:solidFill>
                   <a:srgbClr val="222233"/>
                 </a:solidFill>
                 <a:latin typeface="Calibri"/>
               </a:rPr>
-              <a:t>•  Wycena laptopa wprost wpływa na sprzedaż i marżę (sklepy, marketplace, wycena używanego sprzętu).</a:t>
+              <a:t>•  Szacuje cenę laptopa na podstawie specyfikacji: marki, typu, RAM, dysków, ekranu, CPU/GPU.</a:t>
             </a:r>
           </a:p>
           <a:p>
             <a:pPr algn="l">
               <a:spcAft>
-                <a:spcPts val="1400"/>
+                <a:spcPts val="1600"/>
               </a:spcAft>
             </a:pPr>
             <a:r>
-              <a:rPr sz="1700" b="0">
+              <a:rPr sz="1800" b="0">
                 <a:solidFill>
                   <a:srgbClr val="222233"/>
                 </a:solidFill>
                 <a:latin typeface="Calibri"/>
               </a:rPr>
-              <a:t>•  Za drogo — nie sprzeda się; za tanio — tracimy marżę.</a:t>
+              <a:t>•  Wartość: trafna cena = szybsza sprzedaż i lepsza marża.</a:t>
             </a:r>
           </a:p>
           <a:p>
             <a:pPr algn="l">
               <a:spcAft>
-                <a:spcPts val="1400"/>
+                <a:spcPts val="1600"/>
               </a:spcAft>
             </a:pPr>
             <a:r>
-              <a:rPr sz="1700" b="0">
+              <a:rPr sz="1800" b="0">
                 <a:solidFill>
                   <a:srgbClr val="222233"/>
                 </a:solidFill>
                 <a:latin typeface="Calibri"/>
               </a:rPr>
-              <a:t>•  Aplikacja przewiduje cenę (regresja) z marki, typu, RAM, dysku, ekranu, CPU/GPU i systemu.</a:t>
+              <a:t>•  Dla sklepów, platform marketplace i skupu sprzętu używanego.</a:t>
             </a:r>
           </a:p>
         </p:txBody>
@@ -3822,7 +3822,7 @@
           <a:p>
             <a:pPr algn="l">
               <a:spcAft>
-                <a:spcPts val="800"/>
+                <a:spcPts val="1000"/>
               </a:spcAft>
             </a:pPr>
             <a:r>
@@ -3832,7 +3832,7 @@
                 </a:solidFill>
                 <a:latin typeface="Trebuchet MS"/>
               </a:rPr>
-              <a:t>Dane i czyszczenie</a:t>
+              <a:t>Proste w użyciu</a:t>
             </a:r>
           </a:p>
         </p:txBody>
@@ -3846,7 +3846,7 @@
         <p:spPr>
           <a:xfrm>
             <a:off x="640080" y="1737360"/>
-            <a:ext cx="6035040" cy="4206240"/>
+            <a:ext cx="5120640" cy="4206240"/>
           </a:xfrm>
           <a:prstGeom prst="rect">
             <a:avLst/>
@@ -3861,72 +3861,56 @@
           <a:p>
             <a:pPr algn="l">
               <a:spcAft>
-                <a:spcPts val="1200"/>
+                <a:spcPts val="1600"/>
               </a:spcAft>
             </a:pPr>
             <a:r>
-              <a:rPr sz="1600" b="0">
+              <a:rPr sz="1800" b="0">
                 <a:solidFill>
                   <a:srgbClr val="222233"/>
                 </a:solidFill>
                 <a:latin typeface="Calibri"/>
               </a:rPr>
-              <a:t>•  Źródło: Kaggle laptop price (1303 wiersze) — dołączony do repo.</a:t>
+              <a:t>•  Otwierasz stronę, wpisujesz specyfikację, klikasz — cena w sekundę.</a:t>
             </a:r>
           </a:p>
           <a:p>
             <a:pPr algn="l">
               <a:spcAft>
-                <a:spcPts val="1200"/>
+                <a:spcPts val="1600"/>
               </a:spcAft>
             </a:pPr>
             <a:r>
-              <a:rPr sz="1600" b="0">
+              <a:rPr sz="1800" b="0">
                 <a:solidFill>
                   <a:srgbClr val="222233"/>
                 </a:solidFill>
                 <a:latin typeface="Calibri"/>
               </a:rPr>
-              <a:t>•  Surowe pola to teksty: RAM "8GB", waga "1.37kg", rozdzielczość/CPU/pamięć.</a:t>
+              <a:t>•  Bez instalacji i bez znajomości kodu.</a:t>
             </a:r>
           </a:p>
           <a:p>
             <a:pPr algn="l">
               <a:spcAft>
-                <a:spcPts val="1200"/>
+                <a:spcPts val="1600"/>
               </a:spcAft>
             </a:pPr>
             <a:r>
-              <a:rPr sz="1600" b="0">
+              <a:rPr sz="1800" b="0">
                 <a:solidFill>
                   <a:srgbClr val="222233"/>
                 </a:solidFill>
                 <a:latin typeface="Calibri"/>
               </a:rPr>
-              <a:t>•  features.py: parsowanie → RAM, waga, PPI, touch/IPS, SSD/HDD, marki CPU/GPU; + czyszczenie złych wierszy.</a:t>
-            </a:r>
-          </a:p>
-          <a:p>
-            <a:pPr algn="l">
-              <a:spcAft>
-                <a:spcPts val="1200"/>
-              </a:spcAft>
-            </a:pPr>
-            <a:r>
-              <a:rPr sz="1600" b="0">
-                <a:solidFill>
-                  <a:srgbClr val="222233"/>
-                </a:solidFill>
-                <a:latin typeface="Calibri"/>
-              </a:rPr>
-              <a:t>•  Brak CSV → generator syntetyczny o tym samym schemacie (fallback).</a:t>
+              <a:t>•  Dla integracji z innymi systemami: gotowe API.</a:t>
             </a:r>
           </a:p>
         </p:txBody>
       </p:sp>
       <p:pic>
         <p:nvPicPr>
-          <p:cNvPr id="5" name="Picture 4" descr="target_hist.png"/>
+          <p:cNvPr id="5" name="Picture 4" descr="ui.png"/>
           <p:cNvPicPr>
             <a:picLocks noChangeAspect="1"/>
           </p:cNvPicPr>
@@ -3940,8 +3924,8 @@
         </p:blipFill>
         <p:spPr>
           <a:xfrm>
-            <a:off x="7132320" y="2011680"/>
-            <a:ext cx="4480560" cy="3360420"/>
+            <a:off x="6126480" y="1463040"/>
+            <a:ext cx="5486400" cy="3857625"/>
           </a:xfrm>
           <a:prstGeom prst="rect">
             <a:avLst/>
@@ -4042,7 +4026,7 @@
           <a:p>
             <a:pPr algn="l">
               <a:spcAft>
-                <a:spcPts val="800"/>
+                <a:spcPts val="1000"/>
               </a:spcAft>
             </a:pPr>
             <a:r>
@@ -4052,7 +4036,7 @@
                 </a:solidFill>
                 <a:latin typeface="Trebuchet MS"/>
               </a:rPr>
-              <a:t>Architektura: data | model | app</a:t>
+              <a:t>Na ile trafne?</a:t>
             </a:r>
           </a:p>
         </p:txBody>
@@ -4065,17 +4049,19 @@
         </p:nvSpPr>
         <p:spPr>
           <a:xfrm>
-            <a:off x="822960" y="2377440"/>
-            <a:ext cx="3200400" cy="1828800"/>
+            <a:off x="822960" y="2194560"/>
+            <a:ext cx="3108960" cy="2011680"/>
           </a:xfrm>
           <a:prstGeom prst="roundRect">
             <a:avLst/>
           </a:prstGeom>
           <a:solidFill>
-            <a:srgbClr val="CADCFC"/>
+            <a:srgbClr val="FFFFFF"/>
           </a:solidFill>
-          <a:ln>
-            <a:noFill/>
+          <a:ln w="12700">
+            <a:solidFill>
+              <a:srgbClr val="CADCFC"/>
+            </a:solidFill>
           </a:ln>
           <a:effectLst/>
         </p:spPr>
@@ -4099,336 +4085,93 @@
           <a:p>
             <a:pPr algn="ctr"/>
             <a:r>
-              <a:rPr sz="2600" b="1">
-                <a:solidFill>
-                  <a:srgbClr val="1E2761"/>
+              <a:rPr sz="3800" b="1">
+                <a:solidFill>
+                  <a:srgbClr val="028090"/>
                 </a:solidFill>
                 <a:latin typeface="Trebuchet MS"/>
               </a:rPr>
-              <a:t>data</a:t>
+              <a:t>~85%</a:t>
             </a:r>
           </a:p>
           <a:p>
             <a:pPr algn="ctr"/>
             <a:r>
-              <a:rPr sz="1200">
-                <a:solidFill>
-                  <a:srgbClr val="222233"/>
+              <a:rPr sz="1300">
+                <a:solidFill>
+                  <a:srgbClr val="5A6378"/>
                 </a:solidFill>
                 <a:latin typeface="Calibri"/>
               </a:rPr>
-              <a:t>load + feature engineering</a:t>
-            </a:r>
-          </a:p>
-          <a:p>
-            <a:pPr algn="ctr"/>
-            <a:r>
-              <a:rPr sz="1200">
-                <a:solidFill>
-                  <a:srgbClr val="222233"/>
+              <a:t>zmienności ceny
+wyjaśnia model</a:t>
+            </a:r>
+          </a:p>
+        </p:txBody>
+      </p:sp>
+      <p:sp>
+        <p:nvSpPr>
+          <p:cNvPr id="5" name="TextBox 4"/>
+          <p:cNvSpPr txBox="1"/>
+          <p:nvPr/>
+        </p:nvSpPr>
+        <p:spPr>
+          <a:xfrm>
+            <a:off x="822960" y="4480560"/>
+            <a:ext cx="4754880" cy="1280160"/>
+          </a:xfrm>
+          <a:prstGeom prst="rect">
+            <a:avLst/>
+          </a:prstGeom>
+          <a:noFill/>
+        </p:spPr>
+        <p:txBody>
+          <a:bodyPr wrap="square" anchor="t" lIns="0" rIns="0" tIns="0" bIns="0">
+            <a:spAutoFit/>
+          </a:bodyPr>
+          <a:lstStyle/>
+          <a:p>
+            <a:pPr algn="l">
+              <a:spcAft>
+                <a:spcPts val="1000"/>
+              </a:spcAft>
+            </a:pPr>
+            <a:r>
+              <a:rPr sz="1500" b="0">
+                <a:solidFill>
+                  <a:srgbClr val="5A6378"/>
                 </a:solidFill>
                 <a:latin typeface="Calibri"/>
               </a:rPr>
-              <a:t>czyszczenie + split</a:t>
-            </a:r>
-          </a:p>
-        </p:txBody>
-      </p:sp>
-      <p:sp>
-        <p:nvSpPr>
-          <p:cNvPr id="5" name="Rounded Rectangle 4"/>
-          <p:cNvSpPr/>
+              <a:t>Im więcej danych, tym stabilniejsza wycena. Najważniejsze cechy: RAM, dysk SSD, typ, procesor.</a:t>
+            </a:r>
+          </a:p>
+        </p:txBody>
+      </p:sp>
+      <p:pic>
+        <p:nvPicPr>
+          <p:cNvPr id="6" name="Picture 5" descr="feat_importance.png"/>
+          <p:cNvPicPr>
+            <a:picLocks noChangeAspect="1"/>
+          </p:cNvPicPr>
           <p:nvPr/>
-        </p:nvSpPr>
-        <p:spPr>
-          <a:xfrm>
-            <a:off x="4480560" y="2377440"/>
-            <a:ext cx="3200400" cy="1828800"/>
-          </a:xfrm>
-          <a:prstGeom prst="roundRect">
+        </p:nvPicPr>
+        <p:blipFill>
+          <a:blip r:embed="rId2"/>
+          <a:stretch>
+            <a:fillRect/>
+          </a:stretch>
+        </p:blipFill>
+        <p:spPr>
+          <a:xfrm>
+            <a:off x="6035040" y="1920240"/>
+            <a:ext cx="5669280" cy="3239589"/>
+          </a:xfrm>
+          <a:prstGeom prst="rect">
             <a:avLst/>
           </a:prstGeom>
-          <a:solidFill>
-            <a:srgbClr val="CADCFC"/>
-          </a:solidFill>
-          <a:ln>
-            <a:noFill/>
-          </a:ln>
-          <a:effectLst/>
-        </p:spPr>
-        <p:style>
-          <a:lnRef idx="1">
-            <a:schemeClr val="accent1"/>
-          </a:lnRef>
-          <a:fillRef idx="3">
-            <a:schemeClr val="accent1"/>
-          </a:fillRef>
-          <a:effectRef idx="2">
-            <a:schemeClr val="accent1"/>
-          </a:effectRef>
-          <a:fontRef idx="minor">
-            <a:schemeClr val="lt1"/>
-          </a:fontRef>
-        </p:style>
-        <p:txBody>
-          <a:bodyPr rtlCol="0" anchor="ctr" wrap="square"/>
-          <a:lstStyle/>
-          <a:p>
-            <a:pPr algn="ctr"/>
-            <a:r>
-              <a:rPr sz="2600" b="1">
-                <a:solidFill>
-                  <a:srgbClr val="1E2761"/>
-                </a:solidFill>
-                <a:latin typeface="Trebuchet MS"/>
-              </a:rPr>
-              <a:t>model</a:t>
-            </a:r>
-          </a:p>
-          <a:p>
-            <a:pPr algn="ctr"/>
-            <a:r>
-              <a:rPr sz="1200">
-                <a:solidFill>
-                  <a:srgbClr val="222233"/>
-                </a:solidFill>
-                <a:latin typeface="Calibri"/>
-              </a:rPr>
-              <a:t>FLAML AutoML + log-target</a:t>
-            </a:r>
-          </a:p>
-          <a:p>
-            <a:pPr algn="ctr"/>
-            <a:r>
-              <a:rPr sz="1200">
-                <a:solidFill>
-                  <a:srgbClr val="222233"/>
-                </a:solidFill>
-                <a:latin typeface="Calibri"/>
-              </a:rPr>
-              <a:t>model.joblib + metrics.json</a:t>
-            </a:r>
-          </a:p>
-        </p:txBody>
-      </p:sp>
-      <p:sp>
-        <p:nvSpPr>
-          <p:cNvPr id="6" name="Rounded Rectangle 5"/>
-          <p:cNvSpPr/>
-          <p:nvPr/>
-        </p:nvSpPr>
-        <p:spPr>
-          <a:xfrm>
-            <a:off x="8138160" y="2377440"/>
-            <a:ext cx="3200400" cy="1828800"/>
-          </a:xfrm>
-          <a:prstGeom prst="roundRect">
-            <a:avLst/>
-          </a:prstGeom>
-          <a:solidFill>
-            <a:srgbClr val="CADCFC"/>
-          </a:solidFill>
-          <a:ln>
-            <a:noFill/>
-          </a:ln>
-          <a:effectLst/>
-        </p:spPr>
-        <p:style>
-          <a:lnRef idx="1">
-            <a:schemeClr val="accent1"/>
-          </a:lnRef>
-          <a:fillRef idx="3">
-            <a:schemeClr val="accent1"/>
-          </a:fillRef>
-          <a:effectRef idx="2">
-            <a:schemeClr val="accent1"/>
-          </a:effectRef>
-          <a:fontRef idx="minor">
-            <a:schemeClr val="lt1"/>
-          </a:fontRef>
-        </p:style>
-        <p:txBody>
-          <a:bodyPr rtlCol="0" anchor="ctr" wrap="square"/>
-          <a:lstStyle/>
-          <a:p>
-            <a:pPr algn="ctr"/>
-            <a:r>
-              <a:rPr sz="2600" b="1">
-                <a:solidFill>
-                  <a:srgbClr val="1E2761"/>
-                </a:solidFill>
-                <a:latin typeface="Trebuchet MS"/>
-              </a:rPr>
-              <a:t>app</a:t>
-            </a:r>
-          </a:p>
-          <a:p>
-            <a:pPr algn="ctr"/>
-            <a:r>
-              <a:rPr sz="1200">
-                <a:solidFill>
-                  <a:srgbClr val="222233"/>
-                </a:solidFill>
-                <a:latin typeface="Calibri"/>
-              </a:rPr>
-              <a:t>FastAPI /predict</a:t>
-            </a:r>
-          </a:p>
-          <a:p>
-            <a:pPr algn="ctr"/>
-            <a:r>
-              <a:rPr sz="1200">
-                <a:solidFill>
-                  <a:srgbClr val="222233"/>
-                </a:solidFill>
-                <a:latin typeface="Calibri"/>
-              </a:rPr>
-              <a:t>Streamlit UI</a:t>
-            </a:r>
-          </a:p>
-        </p:txBody>
-      </p:sp>
-      <p:sp>
-        <p:nvSpPr>
-          <p:cNvPr id="7" name="Right Arrow 6"/>
-          <p:cNvSpPr/>
-          <p:nvPr/>
-        </p:nvSpPr>
-        <p:spPr>
-          <a:xfrm>
-            <a:off x="4069080" y="3063240"/>
-            <a:ext cx="365760" cy="457200"/>
-          </a:xfrm>
-          <a:prstGeom prst="rightArrow">
-            <a:avLst/>
-          </a:prstGeom>
-          <a:solidFill>
-            <a:srgbClr val="028090"/>
-          </a:solidFill>
-          <a:ln>
-            <a:noFill/>
-          </a:ln>
-          <a:effectLst/>
-        </p:spPr>
-        <p:style>
-          <a:lnRef idx="1">
-            <a:schemeClr val="accent1"/>
-          </a:lnRef>
-          <a:fillRef idx="3">
-            <a:schemeClr val="accent1"/>
-          </a:fillRef>
-          <a:effectRef idx="2">
-            <a:schemeClr val="accent1"/>
-          </a:effectRef>
-          <a:fontRef idx="minor">
-            <a:schemeClr val="lt1"/>
-          </a:fontRef>
-        </p:style>
-        <p:txBody>
-          <a:bodyPr rtlCol="0" anchor="ctr"/>
-          <a:lstStyle/>
-          <a:p>
-            <a:pPr algn="ctr"/>
-          </a:p>
-        </p:txBody>
-      </p:sp>
-      <p:sp>
-        <p:nvSpPr>
-          <p:cNvPr id="8" name="Right Arrow 7"/>
-          <p:cNvSpPr/>
-          <p:nvPr/>
-        </p:nvSpPr>
-        <p:spPr>
-          <a:xfrm>
-            <a:off x="7726679" y="3063240"/>
-            <a:ext cx="365760" cy="457200"/>
-          </a:xfrm>
-          <a:prstGeom prst="rightArrow">
-            <a:avLst/>
-          </a:prstGeom>
-          <a:solidFill>
-            <a:srgbClr val="028090"/>
-          </a:solidFill>
-          <a:ln>
-            <a:noFill/>
-          </a:ln>
-          <a:effectLst/>
-        </p:spPr>
-        <p:style>
-          <a:lnRef idx="1">
-            <a:schemeClr val="accent1"/>
-          </a:lnRef>
-          <a:fillRef idx="3">
-            <a:schemeClr val="accent1"/>
-          </a:fillRef>
-          <a:effectRef idx="2">
-            <a:schemeClr val="accent1"/>
-          </a:effectRef>
-          <a:fontRef idx="minor">
-            <a:schemeClr val="lt1"/>
-          </a:fontRef>
-        </p:style>
-        <p:txBody>
-          <a:bodyPr rtlCol="0" anchor="ctr"/>
-          <a:lstStyle/>
-          <a:p>
-            <a:pPr algn="ctr"/>
-          </a:p>
-        </p:txBody>
-      </p:sp>
-      <p:sp>
-        <p:nvSpPr>
-          <p:cNvPr id="9" name="Rounded Rectangle 8"/>
-          <p:cNvSpPr/>
-          <p:nvPr/>
-        </p:nvSpPr>
-        <p:spPr>
-          <a:xfrm>
-            <a:off x="822960" y="4663440"/>
-            <a:ext cx="10515600" cy="914400"/>
-          </a:xfrm>
-          <a:prstGeom prst="roundRect">
-            <a:avLst/>
-          </a:prstGeom>
-          <a:solidFill>
-            <a:srgbClr val="1E2761"/>
-          </a:solidFill>
-          <a:ln>
-            <a:noFill/>
-          </a:ln>
-          <a:effectLst/>
-        </p:spPr>
-        <p:style>
-          <a:lnRef idx="1">
-            <a:schemeClr val="accent1"/>
-          </a:lnRef>
-          <a:fillRef idx="3">
-            <a:schemeClr val="accent1"/>
-          </a:fillRef>
-          <a:effectRef idx="2">
-            <a:schemeClr val="accent1"/>
-          </a:effectRef>
-          <a:fontRef idx="minor">
-            <a:schemeClr val="lt1"/>
-          </a:fontRef>
-        </p:style>
-        <p:txBody>
-          <a:bodyPr rtlCol="0" anchor="ctr" wrap="square" lIns="203200"/>
-          <a:lstStyle/>
-          <a:p>
-            <a:pPr algn="ctr"/>
-            <a:r>
-              <a:rPr sz="1600" b="1">
-                <a:solidFill>
-                  <a:srgbClr val="FFFFFF"/>
-                </a:solidFill>
-                <a:latin typeface="Calibri"/>
-              </a:rPr>
-              <a:t>Wszystko sterowane przez config.yaml — zmiana datasetu lub retuning to zmiana configu, nie kodu.</a:t>
-            </a:r>
-          </a:p>
-        </p:txBody>
-      </p:sp>
+        </p:spPr>
+      </p:pic>
     </p:spTree>
   </p:cSld>
   <p:clrMapOvr>
@@ -4523,7 +4266,7 @@
           <a:p>
             <a:pPr algn="l">
               <a:spcAft>
-                <a:spcPts val="800"/>
+                <a:spcPts val="1000"/>
               </a:spcAft>
             </a:pPr>
             <a:r>
@@ -4533,7 +4276,7 @@
                 </a:solidFill>
                 <a:latin typeface="Trebuchet MS"/>
               </a:rPr>
-              <a:t>Model: AutoML (FLAML)</a:t>
+              <a:t>Model nadąża za rynkiem</a:t>
             </a:r>
           </a:p>
         </p:txBody>
@@ -4547,7 +4290,7 @@
         <p:spPr>
           <a:xfrm>
             <a:off x="640080" y="1737360"/>
-            <a:ext cx="6035040" cy="4206240"/>
+            <a:ext cx="10789920" cy="2377440"/>
           </a:xfrm>
           <a:prstGeom prst="rect">
             <a:avLst/>
@@ -4562,93 +4305,106 @@
           <a:p>
             <a:pPr algn="l">
               <a:spcAft>
-                <a:spcPts val="1200"/>
+                <a:spcPts val="1600"/>
               </a:spcAft>
             </a:pPr>
             <a:r>
-              <a:rPr sz="1600" b="0">
+              <a:rPr sz="1800" b="0">
                 <a:solidFill>
                   <a:srgbClr val="222233"/>
                 </a:solidFill>
                 <a:latin typeface="Calibri"/>
               </a:rPr>
-              <a:t>•  AutoML.fit przeszukuje estymatory (lgbm, rf, extra_tree) i składa je w ensemble.</a:t>
+              <a:t>•  Ceny się zmieniają (nowe modele, sezon, promocje) — model można dotrenować.</a:t>
             </a:r>
           </a:p>
           <a:p>
             <a:pPr algn="l">
               <a:spcAft>
-                <a:spcPts val="1200"/>
+                <a:spcPts val="1600"/>
               </a:spcAft>
             </a:pPr>
             <a:r>
-              <a:rPr sz="1600" b="0">
+              <a:rPr sz="1800" b="0">
                 <a:solidFill>
                   <a:srgbClr val="222233"/>
                 </a:solidFill>
                 <a:latin typeface="Calibri"/>
               </a:rPr>
-              <a:t>•  log-target: trenujemy na log(cena), przewidujemy realną cenę (uczciwe R2 w walucie).</a:t>
+              <a:t>•  Dotrenowanie = podmiana pliku z danymi i jedno uruchomienie. Bez zmian w kodzie.</a:t>
             </a:r>
           </a:p>
           <a:p>
             <a:pPr algn="l">
               <a:spcAft>
-                <a:spcPts val="1200"/>
+                <a:spcPts val="1600"/>
               </a:spcAft>
             </a:pPr>
             <a:r>
-              <a:rPr sz="1600" b="0">
+              <a:rPr sz="1800" b="0">
                 <a:solidFill>
                   <a:srgbClr val="222233"/>
                 </a:solidFill>
                 <a:latin typeface="Calibri"/>
               </a:rPr>
-              <a:t>•  Cały preprocessing + model w jednym sklearn Pipeline (model.joblib).</a:t>
-            </a:r>
-          </a:p>
-          <a:p>
-            <a:pPr algn="l">
-              <a:spcAft>
-                <a:spcPts val="1200"/>
-              </a:spcAft>
-            </a:pPr>
-            <a:r>
-              <a:rPr sz="1600" b="0">
-                <a:solidFill>
-                  <a:srgbClr val="222233"/>
-                </a:solidFill>
-                <a:latin typeface="Calibri"/>
-              </a:rPr>
-              <a:t>•  Ważność cech liczona permutacyjnie (model-agnostic).</a:t>
-            </a:r>
-          </a:p>
-        </p:txBody>
-      </p:sp>
-      <p:pic>
-        <p:nvPicPr>
-          <p:cNvPr id="5" name="Picture 4" descr="feat_importance.png"/>
-          <p:cNvPicPr>
-            <a:picLocks noChangeAspect="1"/>
-          </p:cNvPicPr>
+              <a:t>•  Dzięki temu wycena pozostaje aktualna.</a:t>
+            </a:r>
+          </a:p>
+        </p:txBody>
+      </p:sp>
+      <p:sp>
+        <p:nvSpPr>
+          <p:cNvPr id="5" name="Rounded Rectangle 4"/>
+          <p:cNvSpPr/>
           <p:nvPr/>
-        </p:nvPicPr>
-        <p:blipFill>
-          <a:blip r:embed="rId2"/>
-          <a:stretch>
-            <a:fillRect/>
-          </a:stretch>
-        </p:blipFill>
-        <p:spPr>
-          <a:xfrm>
-            <a:off x="6949440" y="2011680"/>
-            <a:ext cx="4754880" cy="2717074"/>
-          </a:xfrm>
-          <a:prstGeom prst="rect">
+        </p:nvSpPr>
+        <p:spPr>
+          <a:xfrm>
+            <a:off x="822960" y="4754880"/>
+            <a:ext cx="10515600" cy="1005840"/>
+          </a:xfrm>
+          <a:prstGeom prst="roundRect">
             <a:avLst/>
           </a:prstGeom>
-        </p:spPr>
-      </p:pic>
+          <a:solidFill>
+            <a:srgbClr val="028090"/>
+          </a:solidFill>
+          <a:ln>
+            <a:noFill/>
+          </a:ln>
+          <a:effectLst/>
+        </p:spPr>
+        <p:style>
+          <a:lnRef idx="1">
+            <a:schemeClr val="accent1"/>
+          </a:lnRef>
+          <a:fillRef idx="3">
+            <a:schemeClr val="accent1"/>
+          </a:fillRef>
+          <a:effectRef idx="2">
+            <a:schemeClr val="accent1"/>
+          </a:effectRef>
+          <a:fontRef idx="minor">
+            <a:schemeClr val="lt1"/>
+          </a:fontRef>
+        </p:style>
+        <p:txBody>
+          <a:bodyPr rtlCol="0" anchor="ctr" wrap="square" lIns="177800" rIns="177800"/>
+          <a:lstStyle/>
+          <a:p>
+            <a:pPr algn="ctr"/>
+            <a:r>
+              <a:rPr sz="2200" b="1">
+                <a:solidFill>
+                  <a:srgbClr val="FFFFFF"/>
+                </a:solidFill>
+                <a:latin typeface="Trebuchet MS"/>
+              </a:rPr>
+              <a:t>Dotrenowanie = nowe dane + 1 komenda → świeży model</a:t>
+            </a:r>
+          </a:p>
+        </p:txBody>
+      </p:sp>
     </p:spTree>
   </p:cSld>
   <p:clrMapOvr>
@@ -4743,7 +4499,7 @@
           <a:p>
             <a:pPr algn="l">
               <a:spcAft>
-                <a:spcPts val="800"/>
+                <a:spcPts val="1000"/>
               </a:spcAft>
             </a:pPr>
             <a:r>
@@ -4753,7 +4509,7 @@
                 </a:solidFill>
                 <a:latin typeface="Trebuchet MS"/>
               </a:rPr>
-              <a:t>Wyniki modelu</a:t>
+              <a:t>Dla ludzi i dla systemów</a:t>
             </a:r>
           </a:p>
         </p:txBody>
@@ -4766,8 +4522,8 @@
         </p:nvSpPr>
         <p:spPr>
           <a:xfrm>
-            <a:off x="822960" y="2286000"/>
-            <a:ext cx="3291840" cy="2011680"/>
+            <a:off x="731520" y="1828800"/>
+            <a:ext cx="5212080" cy="3657600"/>
           </a:xfrm>
           <a:prstGeom prst="roundRect">
             <a:avLst/>
@@ -4797,30 +4553,70 @@
           </a:fontRef>
         </p:style>
         <p:txBody>
-          <a:bodyPr rtlCol="0" anchor="ctr" wrap="square"/>
-          <a:lstStyle/>
-          <a:p>
-            <a:pPr algn="ctr"/>
-            <a:r>
-              <a:rPr sz="3800" b="1">
-                <a:solidFill>
-                  <a:srgbClr val="028090"/>
+          <a:bodyPr rtlCol="0" anchor="ctr" wrap="square" lIns="177800" rIns="177800" tIns="152400" bIns="152400"/>
+          <a:lstStyle/>
+          <a:p>
+            <a:pPr algn="ctr">
+              <a:spcAft>
+                <a:spcPts val="800"/>
+              </a:spcAft>
+            </a:pPr>
+            <a:r>
+              <a:rPr sz="2000" b="1">
+                <a:solidFill>
+                  <a:srgbClr val="1E2761"/>
                 </a:solidFill>
                 <a:latin typeface="Trebuchet MS"/>
               </a:rPr>
-              <a:t>0,85</a:t>
-            </a:r>
-          </a:p>
-          <a:p>
-            <a:pPr algn="ctr"/>
-            <a:r>
-              <a:rPr sz="1300">
-                <a:solidFill>
-                  <a:srgbClr val="5A6378"/>
+              <a:t>Strona (dla ludzi)</a:t>
+            </a:r>
+          </a:p>
+          <a:p>
+            <a:pPr>
+              <a:spcAft>
+                <a:spcPts val="600"/>
+              </a:spcAft>
+            </a:pPr>
+            <a:r>
+              <a:rPr sz="1500">
+                <a:solidFill>
+                  <a:srgbClr val="222233"/>
                 </a:solidFill>
                 <a:latin typeface="Calibri"/>
               </a:rPr>
-              <a:t>R² (cena, INR)</a:t>
+              <a:t>•  Formularz w przeglądarce → cena</a:t>
+            </a:r>
+          </a:p>
+          <a:p>
+            <a:pPr>
+              <a:spcAft>
+                <a:spcPts val="600"/>
+              </a:spcAft>
+            </a:pPr>
+            <a:r>
+              <a:rPr sz="1500">
+                <a:solidFill>
+                  <a:srgbClr val="222233"/>
+                </a:solidFill>
+                <a:latin typeface="Calibri"/>
+              </a:rPr>
+              <a:t>•  Dla pracowników i klientów</a:t>
+            </a:r>
+          </a:p>
+          <a:p>
+            <a:pPr>
+              <a:spcAft>
+                <a:spcPts val="600"/>
+              </a:spcAft>
+            </a:pPr>
+            <a:r>
+              <a:rPr sz="1500">
+                <a:solidFill>
+                  <a:srgbClr val="222233"/>
+                </a:solidFill>
+                <a:latin typeface="Calibri"/>
+              </a:rPr>
+              <a:t>•  Działa też samodzielnie w chmurze</a:t>
             </a:r>
           </a:p>
         </p:txBody>
@@ -4833,8 +4629,8 @@
         </p:nvSpPr>
         <p:spPr>
           <a:xfrm>
-            <a:off x="4434840" y="2286000"/>
-            <a:ext cx="3291840" cy="2011680"/>
+            <a:off x="6217920" y="1828800"/>
+            <a:ext cx="5212080" cy="3657600"/>
           </a:xfrm>
           <a:prstGeom prst="roundRect">
             <a:avLst/>
@@ -4864,121 +4660,7 @@
           </a:fontRef>
         </p:style>
         <p:txBody>
-          <a:bodyPr rtlCol="0" anchor="ctr" wrap="square"/>
-          <a:lstStyle/>
-          <a:p>
-            <a:pPr algn="ctr"/>
-            <a:r>
-              <a:rPr sz="3800" b="1">
-                <a:solidFill>
-                  <a:srgbClr val="028090"/>
-                </a:solidFill>
-                <a:latin typeface="Trebuchet MS"/>
-              </a:rPr>
-              <a:t>9,6k</a:t>
-            </a:r>
-          </a:p>
-          <a:p>
-            <a:pPr algn="ctr"/>
-            <a:r>
-              <a:rPr sz="1300">
-                <a:solidFill>
-                  <a:srgbClr val="5A6378"/>
-                </a:solidFill>
-                <a:latin typeface="Calibri"/>
-              </a:rPr>
-              <a:t>MAE (INR)</a:t>
-            </a:r>
-          </a:p>
-        </p:txBody>
-      </p:sp>
-      <p:sp>
-        <p:nvSpPr>
-          <p:cNvPr id="6" name="Rounded Rectangle 5"/>
-          <p:cNvSpPr/>
-          <p:nvPr/>
-        </p:nvSpPr>
-        <p:spPr>
-          <a:xfrm>
-            <a:off x="8046720" y="2286000"/>
-            <a:ext cx="3291840" cy="2011680"/>
-          </a:xfrm>
-          <a:prstGeom prst="roundRect">
-            <a:avLst/>
-          </a:prstGeom>
-          <a:solidFill>
-            <a:srgbClr val="FFFFFF"/>
-          </a:solidFill>
-          <a:ln w="12700">
-            <a:solidFill>
-              <a:srgbClr val="CADCFC"/>
-            </a:solidFill>
-          </a:ln>
-          <a:effectLst/>
-        </p:spPr>
-        <p:style>
-          <a:lnRef idx="1">
-            <a:schemeClr val="accent1"/>
-          </a:lnRef>
-          <a:fillRef idx="3">
-            <a:schemeClr val="accent1"/>
-          </a:fillRef>
-          <a:effectRef idx="2">
-            <a:schemeClr val="accent1"/>
-          </a:effectRef>
-          <a:fontRef idx="minor">
-            <a:schemeClr val="lt1"/>
-          </a:fontRef>
-        </p:style>
-        <p:txBody>
-          <a:bodyPr rtlCol="0" anchor="ctr" wrap="square"/>
-          <a:lstStyle/>
-          <a:p>
-            <a:pPr algn="ctr"/>
-            <a:r>
-              <a:rPr sz="3800" b="1">
-                <a:solidFill>
-                  <a:srgbClr val="028090"/>
-                </a:solidFill>
-                <a:latin typeface="Trebuchet MS"/>
-              </a:rPr>
-              <a:t>14,6k</a:t>
-            </a:r>
-          </a:p>
-          <a:p>
-            <a:pPr algn="ctr"/>
-            <a:r>
-              <a:rPr sz="1300">
-                <a:solidFill>
-                  <a:srgbClr val="5A6378"/>
-                </a:solidFill>
-                <a:latin typeface="Calibri"/>
-              </a:rPr>
-              <a:t>RMSE (INR)</a:t>
-            </a:r>
-          </a:p>
-        </p:txBody>
-      </p:sp>
-      <p:sp>
-        <p:nvSpPr>
-          <p:cNvPr id="7" name="TextBox 6"/>
-          <p:cNvSpPr txBox="1"/>
-          <p:nvPr/>
-        </p:nvSpPr>
-        <p:spPr>
-          <a:xfrm>
-            <a:off x="822960" y="4663440"/>
-            <a:ext cx="10515600" cy="731520"/>
-          </a:xfrm>
-          <a:prstGeom prst="rect">
-            <a:avLst/>
-          </a:prstGeom>
-          <a:noFill/>
-        </p:spPr>
-        <p:txBody>
-          <a:bodyPr wrap="square" anchor="t" lIns="0" rIns="0" tIns="0" bIns="0">
-            <a:spAutoFit/>
-          </a:bodyPr>
+          <a:bodyPr rtlCol="0" anchor="ctr" wrap="square" lIns="177800" rIns="177800" tIns="152400" bIns="152400"/>
           <a:lstStyle/>
           <a:p>
             <a:pPr algn="ctr">
@@ -4987,13 +4669,61 @@
               </a:spcAft>
             </a:pPr>
             <a:r>
-              <a:rPr sz="1600" b="0">
-                <a:solidFill>
-                  <a:srgbClr val="5A6378"/>
+              <a:rPr sz="2000" b="1">
+                <a:solidFill>
+                  <a:srgbClr val="1E2761"/>
+                </a:solidFill>
+                <a:latin typeface="Trebuchet MS"/>
+              </a:rPr>
+              <a:t>API (dla systemów)</a:t>
+            </a:r>
+          </a:p>
+          <a:p>
+            <a:pPr>
+              <a:spcAft>
+                <a:spcPts val="600"/>
+              </a:spcAft>
+            </a:pPr>
+            <a:r>
+              <a:rPr sz="1500">
+                <a:solidFill>
+                  <a:srgbClr val="222233"/>
                 </a:solidFill>
                 <a:latin typeface="Calibri"/>
               </a:rPr>
-              <a:t>FLAML ensemble + log-target · 20% holdout · najważniejsze cechy: RAM, SSD, typ, CPU.</a:t>
+              <a:t>•  Integracja z e-commerce / ERP</a:t>
+            </a:r>
+          </a:p>
+          <a:p>
+            <a:pPr>
+              <a:spcAft>
+                <a:spcPts val="600"/>
+              </a:spcAft>
+            </a:pPr>
+            <a:r>
+              <a:rPr sz="1500">
+                <a:solidFill>
+                  <a:srgbClr val="222233"/>
+                </a:solidFill>
+                <a:latin typeface="Calibri"/>
+              </a:rPr>
+              <a:t>•  Zwraca cenę w formacie JSON</a:t>
+            </a:r>
+          </a:p>
+          <a:p>
+            <a:pPr>
+              <a:spcAft>
+                <a:spcPts val="600"/>
+              </a:spcAft>
+            </a:pPr>
+            <a:r>
+              <a:rPr sz="1500">
+                <a:solidFill>
+                  <a:srgbClr val="222233"/>
+                </a:solidFill>
+                <a:latin typeface="Calibri"/>
+              </a:rPr>
+              <a:t>•  Interaktywna dokumentacja online</a:t>
             </a:r>
           </a:p>
         </p:txBody>
@@ -5092,7 +4822,7 @@
           <a:p>
             <a:pPr algn="l">
               <a:spcAft>
-                <a:spcPts val="800"/>
+                <a:spcPts val="1000"/>
               </a:spcAft>
             </a:pPr>
             <a:r>
@@ -5102,32 +4832,101 @@
                 </a:solidFill>
                 <a:latin typeface="Trebuchet MS"/>
               </a:rPr>
-              <a:t>Wystawienie: API + UI</a:t>
-            </a:r>
-          </a:p>
-        </p:txBody>
-      </p:sp>
-      <p:sp>
-        <p:nvSpPr>
-          <p:cNvPr id="4" name="Rounded Rectangle 3"/>
+              <a:t>Uruchomienie: jedna komenda</a:t>
+            </a:r>
+          </a:p>
+        </p:txBody>
+      </p:sp>
+      <p:sp>
+        <p:nvSpPr>
+          <p:cNvPr id="4" name="TextBox 3"/>
+          <p:cNvSpPr txBox="1"/>
+          <p:nvPr/>
+        </p:nvSpPr>
+        <p:spPr>
+          <a:xfrm>
+            <a:off x="640080" y="1737360"/>
+            <a:ext cx="10789920" cy="2377440"/>
+          </a:xfrm>
+          <a:prstGeom prst="rect">
+            <a:avLst/>
+          </a:prstGeom>
+          <a:noFill/>
+        </p:spPr>
+        <p:txBody>
+          <a:bodyPr wrap="square" anchor="t" lIns="0" rIns="0" tIns="0" bIns="0">
+            <a:spAutoFit/>
+          </a:bodyPr>
+          <a:lstStyle/>
+          <a:p>
+            <a:pPr algn="l">
+              <a:spcAft>
+                <a:spcPts val="1600"/>
+              </a:spcAft>
+            </a:pPr>
+            <a:r>
+              <a:rPr sz="1800" b="0">
+                <a:solidFill>
+                  <a:srgbClr val="222233"/>
+                </a:solidFill>
+                <a:latin typeface="Calibri"/>
+              </a:rPr>
+              <a:t>•  docker compose up — i działa, na każdym komputerze.</a:t>
+            </a:r>
+          </a:p>
+          <a:p>
+            <a:pPr algn="l">
+              <a:spcAft>
+                <a:spcPts val="1600"/>
+              </a:spcAft>
+            </a:pPr>
+            <a:r>
+              <a:rPr sz="1800" b="0">
+                <a:solidFill>
+                  <a:srgbClr val="222233"/>
+                </a:solidFill>
+                <a:latin typeface="Calibri"/>
+              </a:rPr>
+              <a:t>•  Zero konfiguracji systemu; zależności instalują się same.</a:t>
+            </a:r>
+          </a:p>
+          <a:p>
+            <a:pPr algn="l">
+              <a:spcAft>
+                <a:spcPts val="1600"/>
+              </a:spcAft>
+            </a:pPr>
+            <a:r>
+              <a:rPr sz="1800" b="0">
+                <a:solidFill>
+                  <a:srgbClr val="222233"/>
+                </a:solidFill>
+                <a:latin typeface="Calibri"/>
+              </a:rPr>
+              <a:t>•  Łatwe przeniesienie i odtworzenie środowiska.</a:t>
+            </a:r>
+          </a:p>
+        </p:txBody>
+      </p:sp>
+      <p:sp>
+        <p:nvSpPr>
+          <p:cNvPr id="5" name="Rounded Rectangle 4"/>
           <p:cNvSpPr/>
           <p:nvPr/>
         </p:nvSpPr>
         <p:spPr>
           <a:xfrm>
-            <a:off x="731520" y="1828800"/>
-            <a:ext cx="5212080" cy="3840480"/>
+            <a:off x="822960" y="4754880"/>
+            <a:ext cx="10515600" cy="1005840"/>
           </a:xfrm>
           <a:prstGeom prst="roundRect">
             <a:avLst/>
           </a:prstGeom>
           <a:solidFill>
-            <a:srgbClr val="FFFFFF"/>
+            <a:srgbClr val="028090"/>
           </a:solidFill>
-          <a:ln w="12700">
-            <a:solidFill>
-              <a:srgbClr val="CADCFC"/>
-            </a:solidFill>
+          <a:ln>
+            <a:noFill/>
           </a:ln>
           <a:effectLst/>
         </p:spPr>
@@ -5146,225 +4945,18 @@
           </a:fontRef>
         </p:style>
         <p:txBody>
-          <a:bodyPr rtlCol="0" anchor="ctr" wrap="square" lIns="177800" rIns="177800" tIns="152400" bIns="152400"/>
-          <a:lstStyle/>
-          <a:p>
-            <a:pPr algn="ctr">
-              <a:spcAft>
-                <a:spcPts val="800"/>
-              </a:spcAft>
-            </a:pPr>
-            <a:r>
-              <a:rPr sz="2000" b="1">
-                <a:solidFill>
-                  <a:srgbClr val="1E2761"/>
+          <a:bodyPr rtlCol="0" anchor="ctr" wrap="square" lIns="177800" rIns="177800"/>
+          <a:lstStyle/>
+          <a:p>
+            <a:pPr algn="ctr"/>
+            <a:r>
+              <a:rPr sz="2200" b="1">
+                <a:solidFill>
+                  <a:srgbClr val="FFFFFF"/>
                 </a:solidFill>
                 <a:latin typeface="Trebuchet MS"/>
               </a:rPr>
-              <a:t>FastAPI (usługa)</a:t>
-            </a:r>
-          </a:p>
-          <a:p>
-            <a:pPr>
-              <a:spcAft>
-                <a:spcPts val="600"/>
-              </a:spcAft>
-            </a:pPr>
-            <a:r>
-              <a:rPr sz="1500">
-                <a:solidFill>
-                  <a:srgbClr val="222233"/>
-                </a:solidFill>
-                <a:latin typeface="Calibri"/>
-              </a:rPr>
-              <a:t>•  POST /predict — przewidywana cena</a:t>
-            </a:r>
-          </a:p>
-          <a:p>
-            <a:pPr>
-              <a:spcAft>
-                <a:spcPts val="600"/>
-              </a:spcAft>
-            </a:pPr>
-            <a:r>
-              <a:rPr sz="1500">
-                <a:solidFill>
-                  <a:srgbClr val="222233"/>
-                </a:solidFill>
-                <a:latin typeface="Calibri"/>
-              </a:rPr>
-              <a:t>•  GET /health — status + czy model wczytany</a:t>
-            </a:r>
-          </a:p>
-          <a:p>
-            <a:pPr>
-              <a:spcAft>
-                <a:spcPts val="600"/>
-              </a:spcAft>
-            </a:pPr>
-            <a:r>
-              <a:rPr sz="1500">
-                <a:solidFill>
-                  <a:srgbClr val="222233"/>
-                </a:solidFill>
-                <a:latin typeface="Calibri"/>
-              </a:rPr>
-              <a:t>•  GET /model-info — metryki i metadane</a:t>
-            </a:r>
-          </a:p>
-          <a:p>
-            <a:pPr>
-              <a:spcAft>
-                <a:spcPts val="600"/>
-              </a:spcAft>
-            </a:pPr>
-            <a:r>
-              <a:rPr sz="1500">
-                <a:solidFill>
-                  <a:srgbClr val="222233"/>
-                </a:solidFill>
-                <a:latin typeface="Calibri"/>
-              </a:rPr>
-              <a:t>•  Interaktywne /docs (OpenAPI) za darmo</a:t>
-            </a:r>
-          </a:p>
-          <a:p>
-            <a:pPr>
-              <a:spcAft>
-                <a:spcPts val="600"/>
-              </a:spcAft>
-            </a:pPr>
-            <a:r>
-              <a:rPr sz="1500">
-                <a:solidFill>
-                  <a:srgbClr val="222233"/>
-                </a:solidFill>
-                <a:latin typeface="Calibri"/>
-              </a:rPr>
-              <a:t>•  Walidacja wejścia Pydantic → 422</a:t>
-            </a:r>
-          </a:p>
-        </p:txBody>
-      </p:sp>
-      <p:sp>
-        <p:nvSpPr>
-          <p:cNvPr id="5" name="Rounded Rectangle 4"/>
-          <p:cNvSpPr/>
-          <p:nvPr/>
-        </p:nvSpPr>
-        <p:spPr>
-          <a:xfrm>
-            <a:off x="6217920" y="1828800"/>
-            <a:ext cx="5212080" cy="3840480"/>
-          </a:xfrm>
-          <a:prstGeom prst="roundRect">
-            <a:avLst/>
-          </a:prstGeom>
-          <a:solidFill>
-            <a:srgbClr val="FFFFFF"/>
-          </a:solidFill>
-          <a:ln w="12700">
-            <a:solidFill>
-              <a:srgbClr val="CADCFC"/>
-            </a:solidFill>
-          </a:ln>
-          <a:effectLst/>
-        </p:spPr>
-        <p:style>
-          <a:lnRef idx="1">
-            <a:schemeClr val="accent1"/>
-          </a:lnRef>
-          <a:fillRef idx="3">
-            <a:schemeClr val="accent1"/>
-          </a:fillRef>
-          <a:effectRef idx="2">
-            <a:schemeClr val="accent1"/>
-          </a:effectRef>
-          <a:fontRef idx="minor">
-            <a:schemeClr val="lt1"/>
-          </a:fontRef>
-        </p:style>
-        <p:txBody>
-          <a:bodyPr rtlCol="0" anchor="ctr" wrap="square" lIns="177800" rIns="177800" tIns="152400" bIns="152400"/>
-          <a:lstStyle/>
-          <a:p>
-            <a:pPr algn="ctr">
-              <a:spcAft>
-                <a:spcPts val="800"/>
-              </a:spcAft>
-            </a:pPr>
-            <a:r>
-              <a:rPr sz="2000" b="1">
-                <a:solidFill>
-                  <a:srgbClr val="1E2761"/>
-                </a:solidFill>
-                <a:latin typeface="Trebuchet MS"/>
-              </a:rPr>
-              <a:t>Streamlit (UI)</a:t>
-            </a:r>
-          </a:p>
-          <a:p>
-            <a:pPr>
-              <a:spcAft>
-                <a:spcPts val="600"/>
-              </a:spcAft>
-            </a:pPr>
-            <a:r>
-              <a:rPr sz="1500">
-                <a:solidFill>
-                  <a:srgbClr val="222233"/>
-                </a:solidFill>
-                <a:latin typeface="Calibri"/>
-              </a:rPr>
-              <a:t>•  Formularz specyfikacji laptopa</a:t>
-            </a:r>
-          </a:p>
-          <a:p>
-            <a:pPr>
-              <a:spcAft>
-                <a:spcPts val="600"/>
-              </a:spcAft>
-            </a:pPr>
-            <a:r>
-              <a:rPr sz="1500">
-                <a:solidFill>
-                  <a:srgbClr val="222233"/>
-                </a:solidFill>
-                <a:latin typeface="Calibri"/>
-              </a:rPr>
-              <a:t>•  Woła API i pokazuje cenę</a:t>
-            </a:r>
-          </a:p>
-          <a:p>
-            <a:pPr>
-              <a:spcAft>
-                <a:spcPts val="600"/>
-              </a:spcAft>
-            </a:pPr>
-            <a:r>
-              <a:rPr sz="1500">
-                <a:solidFill>
-                  <a:srgbClr val="222233"/>
-                </a:solidFill>
-                <a:latin typeface="Calibri"/>
-              </a:rPr>
-              <a:t>•  Tryb standalone (model lokalnie) na Streamlit Cloud</a:t>
-            </a:r>
-          </a:p>
-          <a:p>
-            <a:pPr>
-              <a:spcAft>
-                <a:spcPts val="600"/>
-              </a:spcAft>
-            </a:pPr>
-            <a:r>
-              <a:rPr sz="1500">
-                <a:solidFill>
-                  <a:srgbClr val="222233"/>
-                </a:solidFill>
-                <a:latin typeface="Calibri"/>
-              </a:rPr>
-              <a:t>•  Panel z metrykami + ważność cech</a:t>
+              <a:t>Jedna komenda uruchamia całość</a:t>
             </a:r>
           </a:p>
         </p:txBody>
@@ -5463,7 +5055,7 @@
           <a:p>
             <a:pPr algn="l">
               <a:spcAft>
-                <a:spcPts val="800"/>
+                <a:spcPts val="1000"/>
               </a:spcAft>
             </a:pPr>
             <a:r>
@@ -5473,133 +5065,32 @@
                 </a:solidFill>
                 <a:latin typeface="Trebuchet MS"/>
               </a:rPr>
-              <a:t>Przenoszalność i odtwarzalność</a:t>
-            </a:r>
-          </a:p>
-        </p:txBody>
-      </p:sp>
-      <p:sp>
-        <p:nvSpPr>
-          <p:cNvPr id="4" name="TextBox 3"/>
-          <p:cNvSpPr txBox="1"/>
-          <p:nvPr/>
-        </p:nvSpPr>
-        <p:spPr>
-          <a:xfrm>
-            <a:off x="640080" y="1737360"/>
-            <a:ext cx="6583680" cy="4206240"/>
-          </a:xfrm>
-          <a:prstGeom prst="rect">
-            <a:avLst/>
-          </a:prstGeom>
-          <a:noFill/>
-        </p:spPr>
-        <p:txBody>
-          <a:bodyPr wrap="square" anchor="t" lIns="0" rIns="0" tIns="0" bIns="0">
-            <a:spAutoFit/>
-          </a:bodyPr>
-          <a:lstStyle/>
-          <a:p>
-            <a:pPr algn="l">
-              <a:spcAft>
-                <a:spcPts val="1100"/>
-              </a:spcAft>
-            </a:pPr>
-            <a:r>
-              <a:rPr sz="1600" b="0">
-                <a:solidFill>
-                  <a:srgbClr val="222233"/>
-                </a:solidFill>
-                <a:latin typeface="Calibri"/>
-              </a:rPr>
-              <a:t>•  docker compose up --build → dwa serwisy: api + ui.</a:t>
-            </a:r>
-          </a:p>
-          <a:p>
-            <a:pPr algn="l">
-              <a:spcAft>
-                <a:spcPts val="1100"/>
-              </a:spcAft>
-            </a:pPr>
-            <a:r>
-              <a:rPr sz="1600" b="0">
-                <a:solidFill>
-                  <a:srgbClr val="222233"/>
-                </a:solidFill>
-                <a:latin typeface="Calibri"/>
-              </a:rPr>
-              <a:t>•  Model trenowany podczas budowania obrazu — gotowy od razu.</a:t>
-            </a:r>
-          </a:p>
-          <a:p>
-            <a:pPr algn="l">
-              <a:spcAft>
-                <a:spcPts val="1100"/>
-              </a:spcAft>
-            </a:pPr>
-            <a:r>
-              <a:rPr sz="1600" b="0">
-                <a:solidFill>
-                  <a:srgbClr val="222233"/>
-                </a:solidFill>
-                <a:latin typeface="Calibri"/>
-              </a:rPr>
-              <a:t>•  Zależności przypięte; obraz python:3.11-slim, użytkownik non-root.</a:t>
-            </a:r>
-          </a:p>
-          <a:p>
-            <a:pPr algn="l">
-              <a:spcAft>
-                <a:spcPts val="1100"/>
-              </a:spcAft>
-            </a:pPr>
-            <a:r>
-              <a:rPr sz="1600" b="0">
-                <a:solidFill>
-                  <a:srgbClr val="222233"/>
-                </a:solidFill>
-                <a:latin typeface="Calibri"/>
-              </a:rPr>
-              <a:t>•  packages.txt (libgomp1 dla LightGBM); .gitattributes wymusza LF.</a:t>
-            </a:r>
-          </a:p>
-          <a:p>
-            <a:pPr algn="l">
-              <a:spcAft>
-                <a:spcPts val="1100"/>
-              </a:spcAft>
-            </a:pPr>
-            <a:r>
-              <a:rPr sz="1600" b="0">
-                <a:solidFill>
-                  <a:srgbClr val="222233"/>
-                </a:solidFill>
-                <a:latin typeface="Calibri"/>
-              </a:rPr>
-              <a:t>•  config.yaml jako jedno źródło prawdy.</a:t>
-            </a:r>
-          </a:p>
-        </p:txBody>
-      </p:sp>
-      <p:sp>
-        <p:nvSpPr>
-          <p:cNvPr id="5" name="Rounded Rectangle 4"/>
+              <a:t>Zastosowania</a:t>
+            </a:r>
+          </a:p>
+        </p:txBody>
+      </p:sp>
+      <p:sp>
+        <p:nvSpPr>
+          <p:cNvPr id="4" name="Rounded Rectangle 3"/>
           <p:cNvSpPr/>
           <p:nvPr/>
         </p:nvSpPr>
         <p:spPr>
           <a:xfrm>
-            <a:off x="7589520" y="2194560"/>
-            <a:ext cx="3840480" cy="2194560"/>
+            <a:off x="731520" y="1828800"/>
+            <a:ext cx="5212080" cy="3840480"/>
           </a:xfrm>
           <a:prstGeom prst="roundRect">
             <a:avLst/>
           </a:prstGeom>
           <a:solidFill>
-            <a:srgbClr val="028090"/>
+            <a:srgbClr val="FFFFFF"/>
           </a:solidFill>
-          <a:ln>
-            <a:noFill/>
+          <a:ln w="12700">
+            <a:solidFill>
+              <a:srgbClr val="CADCFC"/>
+            </a:solidFill>
           </a:ln>
           <a:effectLst/>
         </p:spPr>
@@ -5618,19 +5109,177 @@
           </a:fontRef>
         </p:style>
         <p:txBody>
-          <a:bodyPr rtlCol="0" anchor="ctr" wrap="square" lIns="177800" rIns="177800"/>
-          <a:lstStyle/>
-          <a:p>
-            <a:pPr algn="ctr"/>
-            <a:r>
-              <a:rPr sz="2400" b="1">
-                <a:solidFill>
-                  <a:srgbClr val="FFFFFF"/>
+          <a:bodyPr rtlCol="0" anchor="ctr" wrap="square" lIns="177800" rIns="177800" tIns="152400" bIns="152400"/>
+          <a:lstStyle/>
+          <a:p>
+            <a:pPr algn="ctr">
+              <a:spcAft>
+                <a:spcPts val="800"/>
+              </a:spcAft>
+            </a:pPr>
+            <a:r>
+              <a:rPr sz="2000" b="1">
+                <a:solidFill>
+                  <a:srgbClr val="1E2761"/>
                 </a:solidFill>
                 <a:latin typeface="Trebuchet MS"/>
               </a:rPr>
-              <a:t>Jedna komenda
-uruchamia całość</a:t>
+              <a:t>Sprzedaż</a:t>
+            </a:r>
+          </a:p>
+          <a:p>
+            <a:pPr>
+              <a:spcAft>
+                <a:spcPts val="600"/>
+              </a:spcAft>
+            </a:pPr>
+            <a:r>
+              <a:rPr sz="1500">
+                <a:solidFill>
+                  <a:srgbClr val="222233"/>
+                </a:solidFill>
+                <a:latin typeface="Calibri"/>
+              </a:rPr>
+              <a:t>•  Szybka wstępna wycena oferty</a:t>
+            </a:r>
+          </a:p>
+          <a:p>
+            <a:pPr>
+              <a:spcAft>
+                <a:spcPts val="600"/>
+              </a:spcAft>
+            </a:pPr>
+            <a:r>
+              <a:rPr sz="1500">
+                <a:solidFill>
+                  <a:srgbClr val="222233"/>
+                </a:solidFill>
+                <a:latin typeface="Calibri"/>
+              </a:rPr>
+              <a:t>•  Weryfikacja, czy cena jest rynkowa</a:t>
+            </a:r>
+          </a:p>
+          <a:p>
+            <a:pPr>
+              <a:spcAft>
+                <a:spcPts val="600"/>
+              </a:spcAft>
+            </a:pPr>
+            <a:r>
+              <a:rPr sz="1500">
+                <a:solidFill>
+                  <a:srgbClr val="222233"/>
+                </a:solidFill>
+                <a:latin typeface="Calibri"/>
+              </a:rPr>
+              <a:t>•  Spójne ceny w całym zespole</a:t>
+            </a:r>
+          </a:p>
+        </p:txBody>
+      </p:sp>
+      <p:sp>
+        <p:nvSpPr>
+          <p:cNvPr id="5" name="Rounded Rectangle 4"/>
+          <p:cNvSpPr/>
+          <p:nvPr/>
+        </p:nvSpPr>
+        <p:spPr>
+          <a:xfrm>
+            <a:off x="6217920" y="1828800"/>
+            <a:ext cx="5212080" cy="3840480"/>
+          </a:xfrm>
+          <a:prstGeom prst="roundRect">
+            <a:avLst/>
+          </a:prstGeom>
+          <a:solidFill>
+            <a:srgbClr val="FFFFFF"/>
+          </a:solidFill>
+          <a:ln w="12700">
+            <a:solidFill>
+              <a:srgbClr val="CADCFC"/>
+            </a:solidFill>
+          </a:ln>
+          <a:effectLst/>
+        </p:spPr>
+        <p:style>
+          <a:lnRef idx="1">
+            <a:schemeClr val="accent1"/>
+          </a:lnRef>
+          <a:fillRef idx="3">
+            <a:schemeClr val="accent1"/>
+          </a:fillRef>
+          <a:effectRef idx="2">
+            <a:schemeClr val="accent1"/>
+          </a:effectRef>
+          <a:fontRef idx="minor">
+            <a:schemeClr val="lt1"/>
+          </a:fontRef>
+        </p:style>
+        <p:txBody>
+          <a:bodyPr rtlCol="0" anchor="ctr" wrap="square" lIns="177800" rIns="177800" tIns="152400" bIns="152400"/>
+          <a:lstStyle/>
+          <a:p>
+            <a:pPr algn="ctr">
+              <a:spcAft>
+                <a:spcPts val="800"/>
+              </a:spcAft>
+            </a:pPr>
+            <a:r>
+              <a:rPr sz="2000" b="1">
+                <a:solidFill>
+                  <a:srgbClr val="1E2761"/>
+                </a:solidFill>
+                <a:latin typeface="Trebuchet MS"/>
+              </a:rPr>
+              <a:t>Skup i integracja</a:t>
+            </a:r>
+          </a:p>
+          <a:p>
+            <a:pPr>
+              <a:spcAft>
+                <a:spcPts val="600"/>
+              </a:spcAft>
+            </a:pPr>
+            <a:r>
+              <a:rPr sz="1500">
+                <a:solidFill>
+                  <a:srgbClr val="222233"/>
+                </a:solidFill>
+                <a:latin typeface="Calibri"/>
+              </a:rPr>
+              <a:t>•  Wycena sprzętu używanego</a:t>
+            </a:r>
+          </a:p>
+          <a:p>
+            <a:pPr>
+              <a:spcAft>
+                <a:spcPts val="600"/>
+              </a:spcAft>
+            </a:pPr>
+            <a:r>
+              <a:rPr sz="1500">
+                <a:solidFill>
+                  <a:srgbClr val="222233"/>
+                </a:solidFill>
+                <a:latin typeface="Calibri"/>
+              </a:rPr>
+              <a:t>•  Wsparcie negocjacji</a:t>
+            </a:r>
+          </a:p>
+          <a:p>
+            <a:pPr>
+              <a:spcAft>
+                <a:spcPts val="600"/>
+              </a:spcAft>
+            </a:pPr>
+            <a:r>
+              <a:rPr sz="1500">
+                <a:solidFill>
+                  <a:srgbClr val="222233"/>
+                </a:solidFill>
+                <a:latin typeface="Calibri"/>
+              </a:rPr>
+              <a:t>•  Automatyczna wycena przez API</a:t>
             </a:r>
           </a:p>
         </p:txBody>
@@ -5729,7 +5378,7 @@
           <a:p>
             <a:pPr algn="l">
               <a:spcAft>
-                <a:spcPts val="800"/>
+                <a:spcPts val="1000"/>
               </a:spcAft>
             </a:pPr>
             <a:r>
@@ -5739,7 +5388,7 @@
                 </a:solidFill>
                 <a:latin typeface="Trebuchet MS"/>
               </a:rPr>
-              <a:t>Jakość kodu i organizacja</a:t>
+              <a:t>Solidne i gotowe do utrzymania</a:t>
             </a:r>
           </a:p>
         </p:txBody>
@@ -5752,8 +5401,8 @@
         </p:nvSpPr>
         <p:spPr>
           <a:xfrm>
-            <a:off x="822960" y="2194560"/>
-            <a:ext cx="3291840" cy="1828800"/>
+            <a:off x="1280160" y="2194560"/>
+            <a:ext cx="3108960" cy="1828800"/>
           </a:xfrm>
           <a:prstGeom prst="roundRect">
             <a:avLst/>
@@ -5806,7 +5455,7 @@
                 </a:solidFill>
                 <a:latin typeface="Calibri"/>
               </a:rPr>
-              <a:t>pylint</a:t>
+              <a:t>jakość kodu (pylint)</a:t>
             </a:r>
           </a:p>
         </p:txBody>
@@ -5819,8 +5468,8 @@
         </p:nvSpPr>
         <p:spPr>
           <a:xfrm>
-            <a:off x="4434840" y="2194560"/>
-            <a:ext cx="3291840" cy="1828800"/>
+            <a:off x="4572000" y="2194560"/>
+            <a:ext cx="3108960" cy="1828800"/>
           </a:xfrm>
           <a:prstGeom prst="roundRect">
             <a:avLst/>
@@ -5873,7 +5522,7 @@
                 </a:solidFill>
                 <a:latin typeface="Calibri"/>
               </a:rPr>
-              <a:t>testów (pytest)</a:t>
+              <a:t>testów automatycznych</a:t>
             </a:r>
           </a:p>
         </p:txBody>
@@ -5886,8 +5535,8 @@
         </p:nvSpPr>
         <p:spPr>
           <a:xfrm>
-            <a:off x="8046720" y="2194560"/>
-            <a:ext cx="3291840" cy="1828800"/>
+            <a:off x="7863840" y="2194560"/>
+            <a:ext cx="3108960" cy="1828800"/>
           </a:xfrm>
           <a:prstGeom prst="roundRect">
             <a:avLst/>
@@ -5940,7 +5589,7 @@
                 </a:solidFill>
                 <a:latin typeface="Calibri"/>
               </a:rPr>
-              <a:t>GitHub Actions</a:t>
+              <a:t>automatyczna kontrola</a:t>
             </a:r>
           </a:p>
         </p:txBody>
@@ -5954,7 +5603,7 @@
         <p:spPr>
           <a:xfrm>
             <a:off x="640080" y="4389120"/>
-            <a:ext cx="10972800" cy="1645920"/>
+            <a:ext cx="10972800" cy="1463040"/>
           </a:xfrm>
           <a:prstGeom prst="rect">
             <a:avLst/>
@@ -5979,7 +5628,7 @@
                 </a:solidFill>
                 <a:latin typeface="Calibri"/>
               </a:rPr>
-              <a:t>•  PEP8 + black + isort, type hints i docstringi w całym kodzie.</a:t>
+              <a:t>•  Czysty, modularny kod (data | model | app) i pełna dokumentacja.</a:t>
             </a:r>
           </a:p>
           <a:p>
@@ -5995,23 +5644,7 @@
                 </a:solidFill>
                 <a:latin typeface="Calibri"/>
               </a:rPr>
-              <a:t>•  Ścisły podział data | model | app; modularność funkcji i katalogów.</a:t>
-            </a:r>
-          </a:p>
-          <a:p>
-            <a:pPr algn="l">
-              <a:spcAft>
-                <a:spcPts val="1000"/>
-              </a:spcAft>
-            </a:pPr>
-            <a:r>
-              <a:rPr sz="1600" b="0">
-                <a:solidFill>
-                  <a:srgbClr val="222233"/>
-                </a:solidFill>
-                <a:latin typeface="Calibri"/>
-              </a:rPr>
-              <a:t>•  Czysta historia commitów; data card + EDA w docs/.</a:t>
+              <a:t>•  Powtarzalne środowisko — łatwe w rozwoju i utrzymaniu.</a:t>
             </a:r>
           </a:p>
         </p:txBody>

</xml_diff>